<commit_message>
Day 3 + Day 4 afternoon + Day 5 accessible: convert remaining OLE equations, fix PUA chars
Day 3 afternoon (5 equations incl. the P-hat table headers), Day 3 morning (4), Day 4
afternoon (4 equations + axis labels; the S49 per-capita growth plot is an OLE chart so
it gets alt text instead). Day 5 had a single Wingdings arrow to fix.

Co-Authored-By: Claude Opus 4.8 <noreply@anthropic.com>
</commit_message>
<xml_diff>
--- a/Day3_MixedModels_ModelSelection/FW536_Day3_Afternoon_hypothesis test and model selection_accessible.pptx
+++ b/Day3_MixedModels_ModelSelection/FW536_Day3_Afternoon_hypothesis test and model selection_accessible.pptx
@@ -26841,101 +26841,6 @@
           </a:p>
         </p:txBody>
       </p:sp>
-      <p:graphicFrame>
-        <p:nvGraphicFramePr>
-          <p:cNvPr id="29698" name="Object 5"/>
-          <p:cNvGraphicFramePr>
-            <a:graphicFrameLocks noGrp="1" noChangeAspect="1"/>
-          </p:cNvGraphicFramePr>
-          <p:nvPr>
-            <p:ph idx="1"/>
-          </p:nvPr>
-        </p:nvGraphicFramePr>
-        <p:xfrm>
-          <a:off x="6937376" y="1298576"/>
-          <a:ext cx="2093913" cy="454025"/>
-        </p:xfrm>
-        <a:graphic>
-          <a:graphicData uri="http://schemas.openxmlformats.org/presentationml/2006/ole">
-            <mc:AlternateContent xmlns:mc="http://schemas.openxmlformats.org/markup-compatibility/2006">
-              <mc:Choice xmlns:v="urn:schemas-microsoft-com:vml" Requires="v">
-                <p:oleObj name="Equation" r:id="rId3" imgW="1054100" imgH="228600" progId="Equation.DSMT4">
-                  <p:embed/>
-                </p:oleObj>
-              </mc:Choice>
-              <mc:Fallback>
-                <p:oleObj name="Equation" r:id="rId3" imgW="1054100" imgH="228600" progId="Equation.DSMT4">
-                  <p:embed/>
-                  <p:pic>
-                    <p:nvPicPr>
-                      <p:cNvPr id="0" name=""/>
-                      <p:cNvPicPr>
-                        <a:picLocks noGrp="1" noChangeAspect="1" noChangeArrowheads="1"/>
-                      </p:cNvPicPr>
-                      <p:nvPr/>
-                    </p:nvPicPr>
-                    <p:blipFill>
-                      <a:blip r:embed="rId4">
-                        <a:extLst>
-                          <a:ext uri="{28A0092B-C50C-407E-A947-70E740481C1C}">
-                            <a14:useLocalDpi xmlns:a14="http://schemas.microsoft.com/office/drawing/2010/main" val="0"/>
-                          </a:ext>
-                        </a:extLst>
-                      </a:blip>
-                      <a:srcRect/>
-                      <a:stretch>
-                        <a:fillRect/>
-                      </a:stretch>
-                    </p:blipFill>
-                    <p:spPr bwMode="auto">
-                      <a:xfrm>
-                        <a:off x="6937376" y="1298576"/>
-                        <a:ext cx="2093913" cy="454025"/>
-                      </a:xfrm>
-                      <a:prstGeom prst="rect">
-                        <a:avLst/>
-                      </a:prstGeom>
-                      <a:noFill/>
-                      <a:ln>
-                        <a:noFill/>
-                      </a:ln>
-                      <a:effectLst/>
-                      <a:extLst>
-                        <a:ext uri="{909E8E84-426E-40DD-AFC4-6F175D3DCCD1}">
-                          <a14:hiddenFill xmlns:a14="http://schemas.microsoft.com/office/drawing/2010/main">
-                            <a:solidFill>
-                              <a:srgbClr val="FFFFFF"/>
-                            </a:solidFill>
-                          </a14:hiddenFill>
-                        </a:ext>
-                        <a:ext uri="{91240B29-F687-4F45-9708-019B960494DF}">
-                          <a14:hiddenLine xmlns:a14="http://schemas.microsoft.com/office/drawing/2010/main" w="9525">
-                            <a:solidFill>
-                              <a:srgbClr val="000000"/>
-                            </a:solidFill>
-                            <a:miter lim="800000"/>
-                            <a:headEnd/>
-                            <a:tailEnd/>
-                          </a14:hiddenLine>
-                        </a:ext>
-                        <a:ext uri="{AF507438-7753-43E0-B8FC-AC1667EBCBE1}">
-                          <a14:hiddenEffects xmlns:a14="http://schemas.microsoft.com/office/drawing/2010/main">
-                            <a:effectLst>
-                              <a:outerShdw dist="35921" dir="2700000" algn="ctr" rotWithShape="0">
-                                <a:srgbClr val="808080"/>
-                              </a:outerShdw>
-                            </a:effectLst>
-                          </a14:hiddenEffects>
-                        </a:ext>
-                      </a:extLst>
-                    </p:spPr>
-                  </p:pic>
-                </p:oleObj>
-              </mc:Fallback>
-            </mc:AlternateContent>
-          </a:graphicData>
-        </a:graphic>
-      </p:graphicFrame>
       <p:sp>
         <p:nvSpPr>
           <p:cNvPr id="8197" name="Slide Number Placeholder 1"/>
@@ -27406,6 +27311,61 @@
                 <a:latin typeface="Tahoma" charset="0"/>
               </a:rPr>
               <a:t>Compute the likelihood ratio</a:t>
+            </a:r>
+          </a:p>
+        </p:txBody>
+      </p:sp>
+      <p:sp>
+        <p:nvSpPr>
+          <p:cNvPr id="29703" name="TextBox 29702"/>
+          <p:cNvSpPr txBox="1"/>
+          <p:nvPr/>
+        </p:nvSpPr>
+        <p:spPr>
+          <a:xfrm>
+            <a:off x="6937376" y="1298576"/>
+            <a:ext cx="2093913" cy="454025"/>
+          </a:xfrm>
+          <a:prstGeom prst="rect">
+            <a:avLst/>
+          </a:prstGeom>
+          <a:noFill/>
+        </p:spPr>
+        <p:txBody>
+          <a:bodyPr wrap="square" anchor="ctr" lIns="0" rIns="0" tIns="0" bIns="0">
+            <a:spAutoFit/>
+          </a:bodyPr>
+          <a:lstStyle/>
+          <a:p>
+            <a:r>
+              <a:rPr sz="1400">
+                <a:latin typeface="Cambria"/>
+              </a:rPr>
+              <a:t>( −ln L</a:t>
+            </a:r>
+            <a:r>
+              <a:rPr sz="1400" baseline="-25000">
+                <a:latin typeface="Cambria"/>
+              </a:rPr>
+              <a:t>A</a:t>
+            </a:r>
+            <a:r>
+              <a:rPr sz="1400">
+                <a:latin typeface="Cambria"/>
+              </a:rPr>
+              <a:t> − (−ln L</a:t>
+            </a:r>
+            <a:r>
+              <a:rPr sz="1400" baseline="-25000">
+                <a:latin typeface="Cambria"/>
+              </a:rPr>
+              <a:t>B</a:t>
+            </a:r>
+            <a:r>
+              <a:rPr sz="1400">
+                <a:latin typeface="Cambria"/>
+              </a:rPr>
+              <a:t>) )</a:t>
             </a:r>
           </a:p>
         </p:txBody>
@@ -27722,101 +27682,6 @@
           </a:p>
         </p:txBody>
       </p:sp>
-      <p:graphicFrame>
-        <p:nvGraphicFramePr>
-          <p:cNvPr id="33794" name="Object 5"/>
-          <p:cNvGraphicFramePr>
-            <a:graphicFrameLocks noGrp="1" noChangeAspect="1"/>
-          </p:cNvGraphicFramePr>
-          <p:nvPr>
-            <p:ph idx="1"/>
-          </p:nvPr>
-        </p:nvGraphicFramePr>
-        <p:xfrm>
-          <a:off x="4148139" y="3276601"/>
-          <a:ext cx="3468687" cy="481013"/>
-        </p:xfrm>
-        <a:graphic>
-          <a:graphicData uri="http://schemas.openxmlformats.org/presentationml/2006/ole">
-            <mc:AlternateContent xmlns:mc="http://schemas.openxmlformats.org/markup-compatibility/2006">
-              <mc:Choice xmlns:v="urn:schemas-microsoft-com:vml" Requires="v">
-                <p:oleObj name="Equation" r:id="rId3" imgW="1739900" imgH="241300" progId="Equation.DSMT4">
-                  <p:embed/>
-                </p:oleObj>
-              </mc:Choice>
-              <mc:Fallback>
-                <p:oleObj name="Equation" r:id="rId3" imgW="1739900" imgH="241300" progId="Equation.DSMT4">
-                  <p:embed/>
-                  <p:pic>
-                    <p:nvPicPr>
-                      <p:cNvPr id="0" name=""/>
-                      <p:cNvPicPr>
-                        <a:picLocks noGrp="1" noChangeAspect="1" noChangeArrowheads="1"/>
-                      </p:cNvPicPr>
-                      <p:nvPr/>
-                    </p:nvPicPr>
-                    <p:blipFill>
-                      <a:blip r:embed="rId4">
-                        <a:extLst>
-                          <a:ext uri="{28A0092B-C50C-407E-A947-70E740481C1C}">
-                            <a14:useLocalDpi xmlns:a14="http://schemas.microsoft.com/office/drawing/2010/main" val="0"/>
-                          </a:ext>
-                        </a:extLst>
-                      </a:blip>
-                      <a:srcRect/>
-                      <a:stretch>
-                        <a:fillRect/>
-                      </a:stretch>
-                    </p:blipFill>
-                    <p:spPr bwMode="auto">
-                      <a:xfrm>
-                        <a:off x="4148139" y="3276601"/>
-                        <a:ext cx="3468687" cy="481013"/>
-                      </a:xfrm>
-                      <a:prstGeom prst="rect">
-                        <a:avLst/>
-                      </a:prstGeom>
-                      <a:noFill/>
-                      <a:ln>
-                        <a:noFill/>
-                      </a:ln>
-                      <a:effectLst/>
-                      <a:extLst>
-                        <a:ext uri="{909E8E84-426E-40DD-AFC4-6F175D3DCCD1}">
-                          <a14:hiddenFill xmlns:a14="http://schemas.microsoft.com/office/drawing/2010/main">
-                            <a:solidFill>
-                              <a:srgbClr val="FFFFFF"/>
-                            </a:solidFill>
-                          </a14:hiddenFill>
-                        </a:ext>
-                        <a:ext uri="{91240B29-F687-4F45-9708-019B960494DF}">
-                          <a14:hiddenLine xmlns:a14="http://schemas.microsoft.com/office/drawing/2010/main" w="9525">
-                            <a:solidFill>
-                              <a:srgbClr val="000000"/>
-                            </a:solidFill>
-                            <a:miter lim="800000"/>
-                            <a:headEnd/>
-                            <a:tailEnd/>
-                          </a14:hiddenLine>
-                        </a:ext>
-                        <a:ext uri="{AF507438-7753-43E0-B8FC-AC1667EBCBE1}">
-                          <a14:hiddenEffects xmlns:a14="http://schemas.microsoft.com/office/drawing/2010/main">
-                            <a:effectLst>
-                              <a:outerShdw dist="35921" dir="2700000" algn="ctr" rotWithShape="0">
-                                <a:srgbClr val="808080"/>
-                              </a:outerShdw>
-                            </a:effectLst>
-                          </a14:hiddenEffects>
-                        </a:ext>
-                      </a:extLst>
-                    </p:spPr>
-                  </p:pic>
-                </p:oleObj>
-              </mc:Fallback>
-            </mc:AlternateContent>
-          </a:graphicData>
-        </a:graphic>
-      </p:graphicFrame>
       <p:sp>
         <p:nvSpPr>
           <p:cNvPr id="9221" name="Slide Number Placeholder 1"/>
@@ -28286,6 +28151,115 @@
             <a:r>
               <a:rPr lang="en-AU" altLang="en-US" dirty="0"/>
               <a:t> more parameters)</a:t>
+            </a:r>
+          </a:p>
+        </p:txBody>
+      </p:sp>
+      <p:sp>
+        <p:nvSpPr>
+          <p:cNvPr id="33794" name="TextBox 33793"/>
+          <p:cNvSpPr txBox="1"/>
+          <p:nvPr/>
+        </p:nvSpPr>
+        <p:spPr>
+          <a:xfrm>
+            <a:off x="4148139" y="3276601"/>
+            <a:ext cx="4923692" cy="481013"/>
+          </a:xfrm>
+          <a:prstGeom prst="rect">
+            <a:avLst/>
+          </a:prstGeom>
+          <a:noFill/>
+        </p:spPr>
+        <p:txBody>
+          <a:bodyPr wrap="square" anchor="ctr" lIns="0" rIns="0" tIns="0" bIns="0">
+            <a:spAutoFit/>
+          </a:bodyPr>
+          <a:lstStyle/>
+          <a:p>
+            <a:r>
+              <a:rPr sz="1900">
+                <a:latin typeface="Cambria"/>
+              </a:rPr>
+              <a:t>L = P</a:t>
+            </a:r>
+            <a:r>
+              <a:rPr sz="1900" baseline="-25000">
+                <a:latin typeface="Cambria"/>
+              </a:rPr>
+              <a:t>1</a:t>
+            </a:r>
+            <a:r>
+              <a:rPr sz="1900" baseline="30000">
+                <a:latin typeface="Cambria"/>
+              </a:rPr>
+              <a:t>30</a:t>
+            </a:r>
+            <a:r>
+              <a:rPr sz="1900">
+                <a:latin typeface="Cambria"/>
+              </a:rPr>
+              <a:t> (1 − P</a:t>
+            </a:r>
+            <a:r>
+              <a:rPr sz="1900" baseline="-25000">
+                <a:latin typeface="Cambria"/>
+              </a:rPr>
+              <a:t>1</a:t>
+            </a:r>
+            <a:r>
+              <a:rPr sz="1900">
+                <a:latin typeface="Cambria"/>
+              </a:rPr>
+              <a:t>)</a:t>
+            </a:r>
+            <a:r>
+              <a:rPr sz="1900" baseline="30000">
+                <a:latin typeface="Cambria"/>
+              </a:rPr>
+              <a:t>20</a:t>
+            </a:r>
+            <a:r>
+              <a:rPr sz="1900">
+                <a:latin typeface="Cambria"/>
+              </a:rPr>
+              <a:t> P</a:t>
+            </a:r>
+            <a:r>
+              <a:rPr sz="1900" baseline="-25000">
+                <a:latin typeface="Cambria"/>
+              </a:rPr>
+              <a:t>2</a:t>
+            </a:r>
+            <a:r>
+              <a:rPr sz="1900" baseline="30000">
+                <a:latin typeface="Cambria"/>
+              </a:rPr>
+              <a:t>10</a:t>
+            </a:r>
+            <a:r>
+              <a:rPr sz="1900">
+                <a:latin typeface="Cambria"/>
+              </a:rPr>
+              <a:t> (1 − P</a:t>
+            </a:r>
+            <a:r>
+              <a:rPr sz="1900" baseline="-25000">
+                <a:latin typeface="Cambria"/>
+              </a:rPr>
+              <a:t>2</a:t>
+            </a:r>
+            <a:r>
+              <a:rPr sz="1900">
+                <a:latin typeface="Cambria"/>
+              </a:rPr>
+              <a:t>)</a:t>
+            </a:r>
+            <a:r>
+              <a:rPr sz="1900" baseline="30000">
+                <a:latin typeface="Cambria"/>
+              </a:rPr>
+              <a:t>40</a:t>
             </a:r>
           </a:p>
         </p:txBody>
@@ -28348,291 +28322,6 @@
           </a:p>
         </p:txBody>
       </p:sp>
-      <p:graphicFrame>
-        <p:nvGraphicFramePr>
-          <p:cNvPr id="35842" name="Object 6"/>
-          <p:cNvGraphicFramePr>
-            <a:graphicFrameLocks noGrp="1" noChangeAspect="1"/>
-          </p:cNvGraphicFramePr>
-          <p:nvPr>
-            <p:ph sz="half" idx="1"/>
-          </p:nvPr>
-        </p:nvGraphicFramePr>
-        <p:xfrm>
-          <a:off x="5484814" y="2201864"/>
-          <a:ext cx="306387" cy="511175"/>
-        </p:xfrm>
-        <a:graphic>
-          <a:graphicData uri="http://schemas.openxmlformats.org/presentationml/2006/ole">
-            <mc:AlternateContent xmlns:mc="http://schemas.openxmlformats.org/markup-compatibility/2006">
-              <mc:Choice xmlns:v="urn:schemas-microsoft-com:vml" Requires="v">
-                <p:oleObj name="Equation" r:id="rId3" imgW="152268" imgH="253780" progId="Equation.DSMT4">
-                  <p:embed/>
-                </p:oleObj>
-              </mc:Choice>
-              <mc:Fallback>
-                <p:oleObj name="Equation" r:id="rId3" imgW="152268" imgH="253780" progId="Equation.DSMT4">
-                  <p:embed/>
-                  <p:pic>
-                    <p:nvPicPr>
-                      <p:cNvPr id="0" name=""/>
-                      <p:cNvPicPr>
-                        <a:picLocks noGrp="1" noChangeAspect="1" noChangeArrowheads="1"/>
-                      </p:cNvPicPr>
-                      <p:nvPr/>
-                    </p:nvPicPr>
-                    <p:blipFill>
-                      <a:blip r:embed="rId4">
-                        <a:extLst>
-                          <a:ext uri="{28A0092B-C50C-407E-A947-70E740481C1C}">
-                            <a14:useLocalDpi xmlns:a14="http://schemas.microsoft.com/office/drawing/2010/main" val="0"/>
-                          </a:ext>
-                        </a:extLst>
-                      </a:blip>
-                      <a:srcRect/>
-                      <a:stretch>
-                        <a:fillRect/>
-                      </a:stretch>
-                    </p:blipFill>
-                    <p:spPr bwMode="auto">
-                      <a:xfrm>
-                        <a:off x="5484814" y="2201864"/>
-                        <a:ext cx="306387" cy="511175"/>
-                      </a:xfrm>
-                      <a:prstGeom prst="rect">
-                        <a:avLst/>
-                      </a:prstGeom>
-                      <a:noFill/>
-                      <a:ln>
-                        <a:noFill/>
-                      </a:ln>
-                      <a:effectLst/>
-                      <a:extLst>
-                        <a:ext uri="{909E8E84-426E-40DD-AFC4-6F175D3DCCD1}">
-                          <a14:hiddenFill xmlns:a14="http://schemas.microsoft.com/office/drawing/2010/main">
-                            <a:solidFill>
-                              <a:srgbClr val="FFFFFF"/>
-                            </a:solidFill>
-                          </a14:hiddenFill>
-                        </a:ext>
-                        <a:ext uri="{91240B29-F687-4F45-9708-019B960494DF}">
-                          <a14:hiddenLine xmlns:a14="http://schemas.microsoft.com/office/drawing/2010/main" w="9525">
-                            <a:solidFill>
-                              <a:srgbClr val="000000"/>
-                            </a:solidFill>
-                            <a:miter lim="800000"/>
-                            <a:headEnd/>
-                            <a:tailEnd/>
-                          </a14:hiddenLine>
-                        </a:ext>
-                        <a:ext uri="{AF507438-7753-43E0-B8FC-AC1667EBCBE1}">
-                          <a14:hiddenEffects xmlns:a14="http://schemas.microsoft.com/office/drawing/2010/main">
-                            <a:effectLst>
-                              <a:outerShdw dist="35921" dir="2700000" algn="ctr" rotWithShape="0">
-                                <a:srgbClr val="808080"/>
-                              </a:outerShdw>
-                            </a:effectLst>
-                          </a14:hiddenEffects>
-                        </a:ext>
-                      </a:extLst>
-                    </p:spPr>
-                  </p:pic>
-                </p:oleObj>
-              </mc:Fallback>
-            </mc:AlternateContent>
-          </a:graphicData>
-        </a:graphic>
-      </p:graphicFrame>
-      <p:graphicFrame>
-        <p:nvGraphicFramePr>
-          <p:cNvPr id="35843" name="Object 8"/>
-          <p:cNvGraphicFramePr>
-            <a:graphicFrameLocks noGrp="1" noChangeAspect="1"/>
-          </p:cNvGraphicFramePr>
-          <p:nvPr>
-            <p:ph sz="quarter" idx="2"/>
-          </p:nvPr>
-        </p:nvGraphicFramePr>
-        <p:xfrm>
-          <a:off x="6705600" y="2201864"/>
-          <a:ext cx="331788" cy="511175"/>
-        </p:xfrm>
-        <a:graphic>
-          <a:graphicData uri="http://schemas.openxmlformats.org/presentationml/2006/ole">
-            <mc:AlternateContent xmlns:mc="http://schemas.openxmlformats.org/markup-compatibility/2006">
-              <mc:Choice xmlns:v="urn:schemas-microsoft-com:vml" Requires="v">
-                <p:oleObj name="Equation" r:id="rId5" imgW="164957" imgH="253780" progId="Equation.DSMT4">
-                  <p:embed/>
-                </p:oleObj>
-              </mc:Choice>
-              <mc:Fallback>
-                <p:oleObj name="Equation" r:id="rId5" imgW="164957" imgH="253780" progId="Equation.DSMT4">
-                  <p:embed/>
-                  <p:pic>
-                    <p:nvPicPr>
-                      <p:cNvPr id="0" name=""/>
-                      <p:cNvPicPr>
-                        <a:picLocks noGrp="1" noChangeAspect="1" noChangeArrowheads="1"/>
-                      </p:cNvPicPr>
-                      <p:nvPr/>
-                    </p:nvPicPr>
-                    <p:blipFill>
-                      <a:blip r:embed="rId6">
-                        <a:extLst>
-                          <a:ext uri="{28A0092B-C50C-407E-A947-70E740481C1C}">
-                            <a14:useLocalDpi xmlns:a14="http://schemas.microsoft.com/office/drawing/2010/main" val="0"/>
-                          </a:ext>
-                        </a:extLst>
-                      </a:blip>
-                      <a:srcRect/>
-                      <a:stretch>
-                        <a:fillRect/>
-                      </a:stretch>
-                    </p:blipFill>
-                    <p:spPr bwMode="auto">
-                      <a:xfrm>
-                        <a:off x="6705600" y="2201864"/>
-                        <a:ext cx="331788" cy="511175"/>
-                      </a:xfrm>
-                      <a:prstGeom prst="rect">
-                        <a:avLst/>
-                      </a:prstGeom>
-                      <a:noFill/>
-                      <a:ln>
-                        <a:noFill/>
-                      </a:ln>
-                      <a:effectLst/>
-                      <a:extLst>
-                        <a:ext uri="{909E8E84-426E-40DD-AFC4-6F175D3DCCD1}">
-                          <a14:hiddenFill xmlns:a14="http://schemas.microsoft.com/office/drawing/2010/main">
-                            <a:solidFill>
-                              <a:srgbClr val="FFFFFF"/>
-                            </a:solidFill>
-                          </a14:hiddenFill>
-                        </a:ext>
-                        <a:ext uri="{91240B29-F687-4F45-9708-019B960494DF}">
-                          <a14:hiddenLine xmlns:a14="http://schemas.microsoft.com/office/drawing/2010/main" w="9525">
-                            <a:solidFill>
-                              <a:srgbClr val="000000"/>
-                            </a:solidFill>
-                            <a:miter lim="800000"/>
-                            <a:headEnd/>
-                            <a:tailEnd/>
-                          </a14:hiddenLine>
-                        </a:ext>
-                        <a:ext uri="{AF507438-7753-43E0-B8FC-AC1667EBCBE1}">
-                          <a14:hiddenEffects xmlns:a14="http://schemas.microsoft.com/office/drawing/2010/main">
-                            <a:effectLst>
-                              <a:outerShdw dist="35921" dir="2700000" algn="ctr" rotWithShape="0">
-                                <a:srgbClr val="808080"/>
-                              </a:outerShdw>
-                            </a:effectLst>
-                          </a14:hiddenEffects>
-                        </a:ext>
-                      </a:extLst>
-                    </p:spPr>
-                  </p:pic>
-                </p:oleObj>
-              </mc:Fallback>
-            </mc:AlternateContent>
-          </a:graphicData>
-        </a:graphic>
-      </p:graphicFrame>
-      <p:graphicFrame>
-        <p:nvGraphicFramePr>
-          <p:cNvPr id="35844" name="Object 10"/>
-          <p:cNvGraphicFramePr>
-            <a:graphicFrameLocks noGrp="1" noChangeAspect="1"/>
-          </p:cNvGraphicFramePr>
-          <p:nvPr>
-            <p:ph sz="quarter" idx="3"/>
-          </p:nvPr>
-        </p:nvGraphicFramePr>
-        <p:xfrm>
-          <a:off x="8305800" y="2278063"/>
-          <a:ext cx="736600" cy="355600"/>
-        </p:xfrm>
-        <a:graphic>
-          <a:graphicData uri="http://schemas.openxmlformats.org/presentationml/2006/ole">
-            <mc:AlternateContent xmlns:mc="http://schemas.openxmlformats.org/markup-compatibility/2006">
-              <mc:Choice xmlns:v="urn:schemas-microsoft-com:vml" Requires="v">
-                <p:oleObj name="Equation" r:id="rId7" imgW="368140" imgH="177723" progId="Equation.DSMT4">
-                  <p:embed/>
-                </p:oleObj>
-              </mc:Choice>
-              <mc:Fallback>
-                <p:oleObj name="Equation" r:id="rId7" imgW="368140" imgH="177723" progId="Equation.DSMT4">
-                  <p:embed/>
-                  <p:pic>
-                    <p:nvPicPr>
-                      <p:cNvPr id="0" name=""/>
-                      <p:cNvPicPr>
-                        <a:picLocks noGrp="1" noChangeAspect="1" noChangeArrowheads="1"/>
-                      </p:cNvPicPr>
-                      <p:nvPr/>
-                    </p:nvPicPr>
-                    <p:blipFill>
-                      <a:blip r:embed="rId8">
-                        <a:extLst>
-                          <a:ext uri="{28A0092B-C50C-407E-A947-70E740481C1C}">
-                            <a14:useLocalDpi xmlns:a14="http://schemas.microsoft.com/office/drawing/2010/main" val="0"/>
-                          </a:ext>
-                        </a:extLst>
-                      </a:blip>
-                      <a:srcRect/>
-                      <a:stretch>
-                        <a:fillRect/>
-                      </a:stretch>
-                    </p:blipFill>
-                    <p:spPr bwMode="auto">
-                      <a:xfrm>
-                        <a:off x="8305800" y="2278063"/>
-                        <a:ext cx="736600" cy="355600"/>
-                      </a:xfrm>
-                      <a:prstGeom prst="rect">
-                        <a:avLst/>
-                      </a:prstGeom>
-                      <a:noFill/>
-                      <a:ln>
-                        <a:noFill/>
-                      </a:ln>
-                      <a:effectLst/>
-                      <a:extLst>
-                        <a:ext uri="{909E8E84-426E-40DD-AFC4-6F175D3DCCD1}">
-                          <a14:hiddenFill xmlns:a14="http://schemas.microsoft.com/office/drawing/2010/main">
-                            <a:solidFill>
-                              <a:srgbClr val="FFFFFF"/>
-                            </a:solidFill>
-                          </a14:hiddenFill>
-                        </a:ext>
-                        <a:ext uri="{91240B29-F687-4F45-9708-019B960494DF}">
-                          <a14:hiddenLine xmlns:a14="http://schemas.microsoft.com/office/drawing/2010/main" w="9525">
-                            <a:solidFill>
-                              <a:srgbClr val="000000"/>
-                            </a:solidFill>
-                            <a:miter lim="800000"/>
-                            <a:headEnd/>
-                            <a:tailEnd/>
-                          </a14:hiddenLine>
-                        </a:ext>
-                        <a:ext uri="{AF507438-7753-43E0-B8FC-AC1667EBCBE1}">
-                          <a14:hiddenEffects xmlns:a14="http://schemas.microsoft.com/office/drawing/2010/main">
-                            <a:effectLst>
-                              <a:outerShdw dist="35921" dir="2700000" algn="ctr" rotWithShape="0">
-                                <a:srgbClr val="808080"/>
-                              </a:outerShdw>
-                            </a:effectLst>
-                          </a14:hiddenEffects>
-                        </a:ext>
-                      </a:extLst>
-                    </p:spPr>
-                  </p:pic>
-                </p:oleObj>
-              </mc:Fallback>
-            </mc:AlternateContent>
-          </a:graphicData>
-        </a:graphic>
-      </p:graphicFrame>
       <p:sp>
         <p:nvSpPr>
           <p:cNvPr id="10245" name="Text Box 4"/>
@@ -29178,6 +28867,111 @@
             <a:r>
               <a:rPr lang="en-AU" altLang="en-US" dirty="0"/>
               <a:t>Is this significant given the difference in parameters is 1?</a:t>
+            </a:r>
+          </a:p>
+        </p:txBody>
+      </p:sp>
+      <p:sp>
+        <p:nvSpPr>
+          <p:cNvPr id="35845" name="TextBox 35844"/>
+          <p:cNvSpPr txBox="1"/>
+          <p:nvPr/>
+        </p:nvSpPr>
+        <p:spPr>
+          <a:xfrm>
+            <a:off x="5484814" y="2201864"/>
+            <a:ext cx="306387" cy="511175"/>
+          </a:xfrm>
+          <a:prstGeom prst="rect">
+            <a:avLst/>
+          </a:prstGeom>
+          <a:noFill/>
+        </p:spPr>
+        <p:txBody>
+          <a:bodyPr wrap="square" anchor="ctr" lIns="0" rIns="0" tIns="0" bIns="0">
+            <a:spAutoFit/>
+          </a:bodyPr>
+          <a:lstStyle/>
+          <a:p>
+            <a:r>
+              <a:rPr sz="2400">
+                <a:latin typeface="Cambria"/>
+              </a:rPr>
+              <a:t>P̂</a:t>
+            </a:r>
+            <a:r>
+              <a:rPr sz="2400" baseline="-25000">
+                <a:latin typeface="Cambria"/>
+              </a:rPr>
+              <a:t>1</a:t>
+            </a:r>
+          </a:p>
+        </p:txBody>
+      </p:sp>
+      <p:sp>
+        <p:nvSpPr>
+          <p:cNvPr id="35846" name="TextBox 35845"/>
+          <p:cNvSpPr txBox="1"/>
+          <p:nvPr/>
+        </p:nvSpPr>
+        <p:spPr>
+          <a:xfrm>
+            <a:off x="6705600" y="2201864"/>
+            <a:ext cx="331788" cy="511175"/>
+          </a:xfrm>
+          <a:prstGeom prst="rect">
+            <a:avLst/>
+          </a:prstGeom>
+          <a:noFill/>
+        </p:spPr>
+        <p:txBody>
+          <a:bodyPr wrap="square" anchor="ctr" lIns="0" rIns="0" tIns="0" bIns="0">
+            <a:spAutoFit/>
+          </a:bodyPr>
+          <a:lstStyle/>
+          <a:p>
+            <a:r>
+              <a:rPr sz="2400">
+                <a:latin typeface="Cambria"/>
+              </a:rPr>
+              <a:t>P̂</a:t>
+            </a:r>
+            <a:r>
+              <a:rPr sz="2400" baseline="-25000">
+                <a:latin typeface="Cambria"/>
+              </a:rPr>
+              <a:t>2</a:t>
+            </a:r>
+          </a:p>
+        </p:txBody>
+      </p:sp>
+      <p:sp>
+        <p:nvSpPr>
+          <p:cNvPr id="35847" name="TextBox 35846"/>
+          <p:cNvSpPr txBox="1"/>
+          <p:nvPr/>
+        </p:nvSpPr>
+        <p:spPr>
+          <a:xfrm>
+            <a:off x="8305800" y="2278063"/>
+            <a:ext cx="736600" cy="355600"/>
+          </a:xfrm>
+          <a:prstGeom prst="rect">
+            <a:avLst/>
+          </a:prstGeom>
+          <a:noFill/>
+        </p:spPr>
+        <p:txBody>
+          <a:bodyPr wrap="square" anchor="ctr" lIns="0" rIns="0" tIns="0" bIns="0">
+            <a:spAutoFit/>
+          </a:bodyPr>
+          <a:lstStyle/>
+          <a:p>
+            <a:r>
+              <a:rPr sz="2400">
+                <a:latin typeface="Cambria"/>
+              </a:rPr>
+              <a:t>−ln L</a:t>
             </a:r>
           </a:p>
         </p:txBody>

</xml_diff>